<commit_message>
Update Apresentação One Time Passwords.pptx
</commit_message>
<xml_diff>
--- a/Apresentação One Time Passwords.pptx
+++ b/Apresentação One Time Passwords.pptx
@@ -896,8 +896,8 @@
         </p:nvSpPr>
         <p:spPr>
           <a:xfrm>
-            <a:off x="1143225" y="685800"/>
-            <a:ext cx="4572225" cy="3429000"/>
+            <a:off x="381000" y="685800"/>
+            <a:ext cx="6096000" cy="3429000"/>
           </a:xfrm>
           <a:custGeom>
             <a:avLst/>
@@ -1000,8 +1000,8 @@
         </p:nvSpPr>
         <p:spPr>
           <a:xfrm>
-            <a:off x="1143225" y="685800"/>
-            <a:ext cx="4572225" cy="3429000"/>
+            <a:off x="381000" y="685800"/>
+            <a:ext cx="6096000" cy="3429000"/>
           </a:xfrm>
           <a:custGeom>
             <a:avLst/>
@@ -1416,8 +1416,8 @@
         </p:nvSpPr>
         <p:spPr>
           <a:xfrm>
-            <a:off x="1143225" y="685800"/>
-            <a:ext cx="4572225" cy="3429000"/>
+            <a:off x="381000" y="685800"/>
+            <a:ext cx="6096000" cy="3429000"/>
           </a:xfrm>
           <a:custGeom>
             <a:avLst/>
@@ -1520,8 +1520,8 @@
         </p:nvSpPr>
         <p:spPr>
           <a:xfrm>
-            <a:off x="1143225" y="685800"/>
-            <a:ext cx="4572225" cy="3429000"/>
+            <a:off x="381000" y="685800"/>
+            <a:ext cx="6096000" cy="3429000"/>
           </a:xfrm>
           <a:custGeom>
             <a:avLst/>
@@ -1624,8 +1624,8 @@
         </p:nvSpPr>
         <p:spPr>
           <a:xfrm>
-            <a:off x="1143225" y="685800"/>
-            <a:ext cx="4572225" cy="3429000"/>
+            <a:off x="381000" y="685800"/>
+            <a:ext cx="6096000" cy="3429000"/>
           </a:xfrm>
           <a:custGeom>
             <a:avLst/>
@@ -1728,8 +1728,8 @@
         </p:nvSpPr>
         <p:spPr>
           <a:xfrm>
-            <a:off x="1143225" y="685800"/>
-            <a:ext cx="4572225" cy="3429000"/>
+            <a:off x="381000" y="685800"/>
+            <a:ext cx="6096000" cy="3429000"/>
           </a:xfrm>
           <a:custGeom>
             <a:avLst/>
@@ -1832,8 +1832,8 @@
         </p:nvSpPr>
         <p:spPr>
           <a:xfrm>
-            <a:off x="1143225" y="685800"/>
-            <a:ext cx="4572225" cy="3429000"/>
+            <a:off x="381000" y="685800"/>
+            <a:ext cx="6096000" cy="3429000"/>
           </a:xfrm>
           <a:custGeom>
             <a:avLst/>
@@ -1936,8 +1936,8 @@
         </p:nvSpPr>
         <p:spPr>
           <a:xfrm>
-            <a:off x="1143225" y="685800"/>
-            <a:ext cx="4572225" cy="3429000"/>
+            <a:off x="381000" y="685800"/>
+            <a:ext cx="6096000" cy="3429000"/>
           </a:xfrm>
           <a:custGeom>
             <a:avLst/>
@@ -2040,8 +2040,8 @@
         </p:nvSpPr>
         <p:spPr>
           <a:xfrm>
-            <a:off x="1143225" y="685800"/>
-            <a:ext cx="4572225" cy="3429000"/>
+            <a:off x="381000" y="685800"/>
+            <a:ext cx="6096000" cy="3429000"/>
           </a:xfrm>
           <a:custGeom>
             <a:avLst/>
@@ -11944,6 +11944,39 @@
           </a:ln>
         </p:spPr>
       </p:pic>
+      <p:pic>
+        <p:nvPicPr>
+          <p:cNvPr id="2" name="Google Shape;278;p25" descr="image.png">
+            <a:extLst>
+              <a:ext uri="{FF2B5EF4-FFF2-40B4-BE49-F238E27FC236}">
+                <a16:creationId xmlns:a16="http://schemas.microsoft.com/office/drawing/2014/main" id="{14A2D07C-58D9-87FA-CD37-FD4394B1A247}"/>
+              </a:ext>
+            </a:extLst>
+          </p:cNvPr>
+          <p:cNvPicPr preferRelativeResize="0"/>
+          <p:nvPr/>
+        </p:nvPicPr>
+        <p:blipFill rotWithShape="1">
+          <a:blip r:embed="rId3">
+            <a:alphaModFix/>
+          </a:blip>
+          <a:srcRect/>
+          <a:stretch/>
+        </p:blipFill>
+        <p:spPr>
+          <a:xfrm>
+            <a:off x="-80925" y="-102412"/>
+            <a:ext cx="12556150" cy="7062826"/>
+          </a:xfrm>
+          <a:prstGeom prst="rect">
+            <a:avLst/>
+          </a:prstGeom>
+          <a:noFill/>
+          <a:ln>
+            <a:noFill/>
+          </a:ln>
+        </p:spPr>
+      </p:pic>
       <p:sp>
         <p:nvSpPr>
           <p:cNvPr id="85" name="Google Shape;85;p13"/>
@@ -12591,6 +12624,39 @@
           <a:xfrm>
             <a:off x="0" y="0"/>
             <a:ext cx="12192000" cy="6858000"/>
+          </a:xfrm>
+          <a:prstGeom prst="rect">
+            <a:avLst/>
+          </a:prstGeom>
+          <a:noFill/>
+          <a:ln>
+            <a:noFill/>
+          </a:ln>
+        </p:spPr>
+      </p:pic>
+      <p:pic>
+        <p:nvPicPr>
+          <p:cNvPr id="2" name="Google Shape;278;p25" descr="image.png">
+            <a:extLst>
+              <a:ext uri="{FF2B5EF4-FFF2-40B4-BE49-F238E27FC236}">
+                <a16:creationId xmlns:a16="http://schemas.microsoft.com/office/drawing/2014/main" id="{BCDE4229-96B8-16C7-A8E0-679EDFBF50DF}"/>
+              </a:ext>
+            </a:extLst>
+          </p:cNvPr>
+          <p:cNvPicPr preferRelativeResize="0"/>
+          <p:nvPr/>
+        </p:nvPicPr>
+        <p:blipFill rotWithShape="1">
+          <a:blip r:embed="rId3">
+            <a:alphaModFix/>
+          </a:blip>
+          <a:srcRect/>
+          <a:stretch/>
+        </p:blipFill>
+        <p:spPr>
+          <a:xfrm>
+            <a:off x="-80925" y="-102412"/>
+            <a:ext cx="12556150" cy="7062826"/>
           </a:xfrm>
           <a:prstGeom prst="rect">
             <a:avLst/>
@@ -13176,6 +13242,39 @@
       </p:pic>
       <p:pic>
         <p:nvPicPr>
+          <p:cNvPr id="2" name="Google Shape;278;p25" descr="image.png">
+            <a:extLst>
+              <a:ext uri="{FF2B5EF4-FFF2-40B4-BE49-F238E27FC236}">
+                <a16:creationId xmlns:a16="http://schemas.microsoft.com/office/drawing/2014/main" id="{B530C4DE-4691-BB8D-70FB-15A3F32787A0}"/>
+              </a:ext>
+            </a:extLst>
+          </p:cNvPr>
+          <p:cNvPicPr preferRelativeResize="0"/>
+          <p:nvPr/>
+        </p:nvPicPr>
+        <p:blipFill rotWithShape="1">
+          <a:blip r:embed="rId3">
+            <a:alphaModFix/>
+          </a:blip>
+          <a:srcRect/>
+          <a:stretch/>
+        </p:blipFill>
+        <p:spPr>
+          <a:xfrm>
+            <a:off x="-80925" y="-102412"/>
+            <a:ext cx="12556150" cy="7062826"/>
+          </a:xfrm>
+          <a:prstGeom prst="rect">
+            <a:avLst/>
+          </a:prstGeom>
+          <a:noFill/>
+          <a:ln>
+            <a:noFill/>
+          </a:ln>
+        </p:spPr>
+      </p:pic>
+      <p:pic>
+        <p:nvPicPr>
           <p:cNvPr id="257" name="Google Shape;257;p23" descr="image.png"/>
           <p:cNvPicPr preferRelativeResize="0"/>
           <p:nvPr/>
@@ -13473,7 +13572,7 @@
         <p:spPr>
           <a:xfrm>
             <a:off x="771525" y="581025"/>
-            <a:ext cx="11381422" cy="439935"/>
+            <a:ext cx="11381422" cy="533223"/>
           </a:xfrm>
           <a:prstGeom prst="rect">
             <a:avLst/>
@@ -13502,7 +13601,7 @@
               <a:buNone/>
             </a:pPr>
             <a:r>
-              <a:rPr lang="en-US" sz="3150" b="1" i="0" u="none" strike="noStrike" cap="none">
+              <a:rPr lang="en-US" sz="3150" b="1" i="0" u="none" strike="noStrike" cap="none" dirty="0">
                 <a:solidFill>
                   <a:srgbClr val="F8FAFC"/>
                 </a:solidFill>
@@ -13511,9 +13610,9 @@
                 <a:cs typeface="Space Grotesk"/>
                 <a:sym typeface="Space Grotesk"/>
               </a:rPr>
-              <a:t>O Futuro: Passwordless</a:t>
+              <a:t>O Futuro</a:t>
             </a:r>
-            <a:endParaRPr/>
+            <a:endParaRPr dirty="0"/>
           </a:p>
         </p:txBody>
       </p:sp>
@@ -14807,6 +14906,39 @@
       </p:pic>
       <p:pic>
         <p:nvPicPr>
+          <p:cNvPr id="2" name="Google Shape;278;p25" descr="image.png">
+            <a:extLst>
+              <a:ext uri="{FF2B5EF4-FFF2-40B4-BE49-F238E27FC236}">
+                <a16:creationId xmlns:a16="http://schemas.microsoft.com/office/drawing/2014/main" id="{46D5219F-5407-9B36-B59B-7324384A487A}"/>
+              </a:ext>
+            </a:extLst>
+          </p:cNvPr>
+          <p:cNvPicPr preferRelativeResize="0"/>
+          <p:nvPr/>
+        </p:nvPicPr>
+        <p:blipFill rotWithShape="1">
+          <a:blip r:embed="rId3">
+            <a:alphaModFix/>
+          </a:blip>
+          <a:srcRect/>
+          <a:stretch/>
+        </p:blipFill>
+        <p:spPr>
+          <a:xfrm>
+            <a:off x="-80925" y="-102412"/>
+            <a:ext cx="12556150" cy="7062826"/>
+          </a:xfrm>
+          <a:prstGeom prst="rect">
+            <a:avLst/>
+          </a:prstGeom>
+          <a:noFill/>
+          <a:ln>
+            <a:noFill/>
+          </a:ln>
+        </p:spPr>
+      </p:pic>
+      <p:pic>
+        <p:nvPicPr>
           <p:cNvPr id="100" name="Google Shape;100;p14" descr="image.png"/>
           <p:cNvPicPr preferRelativeResize="0"/>
           <p:nvPr/>
@@ -16062,6 +16194,39 @@
       </p:pic>
       <p:pic>
         <p:nvPicPr>
+          <p:cNvPr id="2" name="Google Shape;278;p25" descr="image.png">
+            <a:extLst>
+              <a:ext uri="{FF2B5EF4-FFF2-40B4-BE49-F238E27FC236}">
+                <a16:creationId xmlns:a16="http://schemas.microsoft.com/office/drawing/2014/main" id="{220EA920-0C6C-9978-871E-0A70B6F729E7}"/>
+              </a:ext>
+            </a:extLst>
+          </p:cNvPr>
+          <p:cNvPicPr preferRelativeResize="0"/>
+          <p:nvPr/>
+        </p:nvPicPr>
+        <p:blipFill rotWithShape="1">
+          <a:blip r:embed="rId3">
+            <a:alphaModFix/>
+          </a:blip>
+          <a:srcRect/>
+          <a:stretch/>
+        </p:blipFill>
+        <p:spPr>
+          <a:xfrm>
+            <a:off x="-80925" y="-102412"/>
+            <a:ext cx="12556150" cy="7062826"/>
+          </a:xfrm>
+          <a:prstGeom prst="rect">
+            <a:avLst/>
+          </a:prstGeom>
+          <a:noFill/>
+          <a:ln>
+            <a:noFill/>
+          </a:ln>
+        </p:spPr>
+      </p:pic>
+      <p:pic>
+        <p:nvPicPr>
           <p:cNvPr id="115" name="Google Shape;115;p15" descr="image.png"/>
           <p:cNvPicPr preferRelativeResize="0"/>
           <p:nvPr/>
@@ -16598,6 +16763,39 @@
       </p:pic>
       <p:pic>
         <p:nvPicPr>
+          <p:cNvPr id="2" name="Google Shape;278;p25" descr="image.png">
+            <a:extLst>
+              <a:ext uri="{FF2B5EF4-FFF2-40B4-BE49-F238E27FC236}">
+                <a16:creationId xmlns:a16="http://schemas.microsoft.com/office/drawing/2014/main" id="{7F248A15-9981-6AA7-5E75-D6CBF8E72310}"/>
+              </a:ext>
+            </a:extLst>
+          </p:cNvPr>
+          <p:cNvPicPr preferRelativeResize="0"/>
+          <p:nvPr/>
+        </p:nvPicPr>
+        <p:blipFill rotWithShape="1">
+          <a:blip r:embed="rId3">
+            <a:alphaModFix/>
+          </a:blip>
+          <a:srcRect/>
+          <a:stretch/>
+        </p:blipFill>
+        <p:spPr>
+          <a:xfrm>
+            <a:off x="-80925" y="-102412"/>
+            <a:ext cx="12556150" cy="7062826"/>
+          </a:xfrm>
+          <a:prstGeom prst="rect">
+            <a:avLst/>
+          </a:prstGeom>
+          <a:noFill/>
+          <a:ln>
+            <a:noFill/>
+          </a:ln>
+        </p:spPr>
+      </p:pic>
+      <p:pic>
+        <p:nvPicPr>
           <p:cNvPr id="131" name="Google Shape;131;p16" descr="image.png"/>
           <p:cNvPicPr preferRelativeResize="0"/>
           <p:nvPr/>
@@ -17279,6 +17477,39 @@
       </p:pic>
       <p:pic>
         <p:nvPicPr>
+          <p:cNvPr id="2" name="Google Shape;278;p25" descr="image.png">
+            <a:extLst>
+              <a:ext uri="{FF2B5EF4-FFF2-40B4-BE49-F238E27FC236}">
+                <a16:creationId xmlns:a16="http://schemas.microsoft.com/office/drawing/2014/main" id="{4F2FAEA3-879C-8305-1DA7-BAA01844C4FE}"/>
+              </a:ext>
+            </a:extLst>
+          </p:cNvPr>
+          <p:cNvPicPr preferRelativeResize="0"/>
+          <p:nvPr/>
+        </p:nvPicPr>
+        <p:blipFill rotWithShape="1">
+          <a:blip r:embed="rId3">
+            <a:alphaModFix/>
+          </a:blip>
+          <a:srcRect/>
+          <a:stretch/>
+        </p:blipFill>
+        <p:spPr>
+          <a:xfrm>
+            <a:off x="-80925" y="-102412"/>
+            <a:ext cx="12556150" cy="7062826"/>
+          </a:xfrm>
+          <a:prstGeom prst="rect">
+            <a:avLst/>
+          </a:prstGeom>
+          <a:noFill/>
+          <a:ln>
+            <a:noFill/>
+          </a:ln>
+        </p:spPr>
+      </p:pic>
+      <p:pic>
+        <p:nvPicPr>
           <p:cNvPr id="150" name="Google Shape;150;p17" descr="image.png"/>
           <p:cNvPicPr preferRelativeResize="0"/>
           <p:nvPr/>
@@ -18467,6 +18698,39 @@
       </p:pic>
       <p:pic>
         <p:nvPicPr>
+          <p:cNvPr id="2" name="Google Shape;278;p25" descr="image.png">
+            <a:extLst>
+              <a:ext uri="{FF2B5EF4-FFF2-40B4-BE49-F238E27FC236}">
+                <a16:creationId xmlns:a16="http://schemas.microsoft.com/office/drawing/2014/main" id="{98EEA8CE-17D7-D948-4F57-BD6782F432EA}"/>
+              </a:ext>
+            </a:extLst>
+          </p:cNvPr>
+          <p:cNvPicPr preferRelativeResize="0"/>
+          <p:nvPr/>
+        </p:nvPicPr>
+        <p:blipFill rotWithShape="1">
+          <a:blip r:embed="rId3">
+            <a:alphaModFix/>
+          </a:blip>
+          <a:srcRect/>
+          <a:stretch/>
+        </p:blipFill>
+        <p:spPr>
+          <a:xfrm>
+            <a:off x="-80925" y="-102412"/>
+            <a:ext cx="12556150" cy="7062826"/>
+          </a:xfrm>
+          <a:prstGeom prst="rect">
+            <a:avLst/>
+          </a:prstGeom>
+          <a:noFill/>
+          <a:ln>
+            <a:noFill/>
+          </a:ln>
+        </p:spPr>
+      </p:pic>
+      <p:pic>
+        <p:nvPicPr>
           <p:cNvPr id="177" name="Google Shape;177;p18" descr="image.png"/>
           <p:cNvPicPr preferRelativeResize="0"/>
           <p:nvPr/>
@@ -19140,6 +19404,39 @@
       </p:pic>
       <p:pic>
         <p:nvPicPr>
+          <p:cNvPr id="2" name="Google Shape;278;p25" descr="image.png">
+            <a:extLst>
+              <a:ext uri="{FF2B5EF4-FFF2-40B4-BE49-F238E27FC236}">
+                <a16:creationId xmlns:a16="http://schemas.microsoft.com/office/drawing/2014/main" id="{3E1DA7A2-5D91-22DE-9972-70402A278466}"/>
+              </a:ext>
+            </a:extLst>
+          </p:cNvPr>
+          <p:cNvPicPr preferRelativeResize="0"/>
+          <p:nvPr/>
+        </p:nvPicPr>
+        <p:blipFill rotWithShape="1">
+          <a:blip r:embed="rId3">
+            <a:alphaModFix/>
+          </a:blip>
+          <a:srcRect/>
+          <a:stretch/>
+        </p:blipFill>
+        <p:spPr>
+          <a:xfrm>
+            <a:off x="-80925" y="-102412"/>
+            <a:ext cx="12556150" cy="7062826"/>
+          </a:xfrm>
+          <a:prstGeom prst="rect">
+            <a:avLst/>
+          </a:prstGeom>
+          <a:noFill/>
+          <a:ln>
+            <a:noFill/>
+          </a:ln>
+        </p:spPr>
+      </p:pic>
+      <p:pic>
+        <p:nvPicPr>
           <p:cNvPr id="194" name="Google Shape;194;p19" descr="image.png"/>
           <p:cNvPicPr preferRelativeResize="0"/>
           <p:nvPr/>
@@ -19791,6 +20088,39 @@
       </p:pic>
       <p:pic>
         <p:nvPicPr>
+          <p:cNvPr id="2" name="Google Shape;278;p25" descr="image.png">
+            <a:extLst>
+              <a:ext uri="{FF2B5EF4-FFF2-40B4-BE49-F238E27FC236}">
+                <a16:creationId xmlns:a16="http://schemas.microsoft.com/office/drawing/2014/main" id="{220B3C8D-5632-232F-E9BF-E7BC1D6A3E19}"/>
+              </a:ext>
+            </a:extLst>
+          </p:cNvPr>
+          <p:cNvPicPr preferRelativeResize="0"/>
+          <p:nvPr/>
+        </p:nvPicPr>
+        <p:blipFill rotWithShape="1">
+          <a:blip r:embed="rId3">
+            <a:alphaModFix/>
+          </a:blip>
+          <a:srcRect/>
+          <a:stretch/>
+        </p:blipFill>
+        <p:spPr>
+          <a:xfrm>
+            <a:off x="-80925" y="-102412"/>
+            <a:ext cx="12556150" cy="7062826"/>
+          </a:xfrm>
+          <a:prstGeom prst="rect">
+            <a:avLst/>
+          </a:prstGeom>
+          <a:noFill/>
+          <a:ln>
+            <a:noFill/>
+          </a:ln>
+        </p:spPr>
+      </p:pic>
+      <p:pic>
+        <p:nvPicPr>
           <p:cNvPr id="211" name="Google Shape;211;p20" descr="image.png"/>
           <p:cNvPicPr preferRelativeResize="0"/>
           <p:nvPr/>
@@ -20423,6 +20753,39 @@
           <a:xfrm>
             <a:off x="0" y="0"/>
             <a:ext cx="12192000" cy="6858000"/>
+          </a:xfrm>
+          <a:prstGeom prst="rect">
+            <a:avLst/>
+          </a:prstGeom>
+          <a:noFill/>
+          <a:ln>
+            <a:noFill/>
+          </a:ln>
+        </p:spPr>
+      </p:pic>
+      <p:pic>
+        <p:nvPicPr>
+          <p:cNvPr id="2" name="Google Shape;278;p25" descr="image.png">
+            <a:extLst>
+              <a:ext uri="{FF2B5EF4-FFF2-40B4-BE49-F238E27FC236}">
+                <a16:creationId xmlns:a16="http://schemas.microsoft.com/office/drawing/2014/main" id="{E0117530-DF5F-C43E-986E-FA761BDABBD4}"/>
+              </a:ext>
+            </a:extLst>
+          </p:cNvPr>
+          <p:cNvPicPr preferRelativeResize="0"/>
+          <p:nvPr/>
+        </p:nvPicPr>
+        <p:blipFill rotWithShape="1">
+          <a:blip r:embed="rId3">
+            <a:alphaModFix/>
+          </a:blip>
+          <a:srcRect/>
+          <a:stretch/>
+        </p:blipFill>
+        <p:spPr>
+          <a:xfrm>
+            <a:off x="-80925" y="-102412"/>
+            <a:ext cx="12556150" cy="7062826"/>
           </a:xfrm>
           <a:prstGeom prst="rect">
             <a:avLst/>

</xml_diff>